<commit_message>
docs: update academic report DOCX, PDF, presentation PPTX and remove video guide note
</commit_message>
<xml_diff>
--- a/docs/reports/presentasi-proyek.pptx
+++ b/docs/reports/presentasi-proyek.pptx
@@ -5,16 +5,16 @@
     <p:sldMasterId id="2147483648" r:id="rId1"/>
   </p:sldMasterIdLst>
   <p:sldIdLst>
-    <p:sldId id="256" r:id="rId7"/>
-    <p:sldId id="257" r:id="rId8"/>
-    <p:sldId id="258" r:id="rId9"/>
-    <p:sldId id="259" r:id="rId10"/>
-    <p:sldId id="260" r:id="rId11"/>
-    <p:sldId id="261" r:id="rId12"/>
-    <p:sldId id="262" r:id="rId13"/>
-    <p:sldId id="263" r:id="rId14"/>
+    <p:sldId id="256" r:id="rId2"/>
+    <p:sldId id="257" r:id="rId3"/>
+    <p:sldId id="258" r:id="rId4"/>
+    <p:sldId id="259" r:id="rId5"/>
+    <p:sldId id="260" r:id="rId6"/>
+    <p:sldId id="261" r:id="rId7"/>
+    <p:sldId id="262" r:id="rId8"/>
+    <p:sldId id="263" r:id="rId9"/>
   </p:sldIdLst>
-  <p:sldSz cx="12191695" cy="6858000" type="screen4x3"/>
+  <p:sldSz cx="12192000" cy="6858000"/>
   <p:notesSz cx="6858000" cy="9144000"/>
   <p:defaultTextStyle>
     <a:defPPr>
@@ -111,6 +111,22 @@
       </a:defRPr>
     </a:lvl9pPr>
   </p:defaultTextStyle>
+  <p:extLst>
+    <p:ext uri="{EFAFB233-063F-42B5-8137-9DF3F51BA10A}">
+      <p15:sldGuideLst xmlns:p15="http://schemas.microsoft.com/office/powerpoint/2012/main">
+        <p15:guide id="1" orient="horz" pos="2160">
+          <p15:clr>
+            <a:srgbClr val="A4A3A4"/>
+          </p15:clr>
+        </p15:guide>
+        <p15:guide id="2" pos="2880">
+          <p15:clr>
+            <a:srgbClr val="A4A3A4"/>
+          </p15:clr>
+        </p15:guide>
+      </p15:sldGuideLst>
+    </p:ext>
+  </p:extLst>
 </p:presentation>
 </file>
 
@@ -152,10 +168,9 @@
           <a:lstStyle/>
           <a:p>
             <a:r>
-              <a:rPr lang="en-US" smtClean="0"/>
+              <a:rPr lang="en-US"/>
               <a:t>Click to edit Master title style</a:t>
             </a:r>
-            <a:endParaRPr lang="en-US"/>
           </a:p>
         </p:txBody>
       </p:sp>
@@ -271,10 +286,9 @@
           </a:lstStyle>
           <a:p>
             <a:r>
-              <a:rPr lang="en-US" smtClean="0"/>
+              <a:rPr lang="en-US"/>
               <a:t>Click to edit Master subtitle style</a:t>
             </a:r>
-            <a:endParaRPr lang="en-US"/>
           </a:p>
         </p:txBody>
       </p:sp>
@@ -295,7 +309,7 @@
           <a:p>
             <a:fld id="{5BCAD085-E8A6-8845-BD4E-CB4CCA059FC4}" type="datetimeFigureOut">
               <a:rPr lang="en-US" smtClean="0"/>
-              <a:t>1/27/13</a:t>
+              <a:t>7/21/2026</a:t>
             </a:fld>
             <a:endParaRPr lang="en-US"/>
           </a:p>
@@ -389,10 +403,9 @@
           <a:lstStyle/>
           <a:p>
             <a:r>
-              <a:rPr lang="en-US" smtClean="0"/>
+              <a:rPr lang="en-US"/>
               <a:t>Click to edit Master title style</a:t>
             </a:r>
-            <a:endParaRPr lang="en-US"/>
           </a:p>
         </p:txBody>
       </p:sp>
@@ -413,38 +426,37 @@
           <a:p>
             <a:pPr lvl="0"/>
             <a:r>
-              <a:rPr lang="en-US" smtClean="0"/>
+              <a:rPr lang="en-US"/>
               <a:t>Click to edit Master text styles</a:t>
             </a:r>
           </a:p>
           <a:p>
             <a:pPr lvl="1"/>
             <a:r>
-              <a:rPr lang="en-US" smtClean="0"/>
+              <a:rPr lang="en-US"/>
               <a:t>Second level</a:t>
             </a:r>
           </a:p>
           <a:p>
             <a:pPr lvl="2"/>
             <a:r>
-              <a:rPr lang="en-US" smtClean="0"/>
+              <a:rPr lang="en-US"/>
               <a:t>Third level</a:t>
             </a:r>
           </a:p>
           <a:p>
             <a:pPr lvl="3"/>
             <a:r>
-              <a:rPr lang="en-US" smtClean="0"/>
+              <a:rPr lang="en-US"/>
               <a:t>Fourth level</a:t>
             </a:r>
           </a:p>
           <a:p>
             <a:pPr lvl="4"/>
             <a:r>
-              <a:rPr lang="en-US" smtClean="0"/>
+              <a:rPr lang="en-US"/>
               <a:t>Fifth level</a:t>
             </a:r>
-            <a:endParaRPr lang="en-US"/>
           </a:p>
         </p:txBody>
       </p:sp>
@@ -465,7 +477,7 @@
           <a:p>
             <a:fld id="{5BCAD085-E8A6-8845-BD4E-CB4CCA059FC4}" type="datetimeFigureOut">
               <a:rPr lang="en-US" smtClean="0"/>
-              <a:t>1/27/13</a:t>
+              <a:t>7/21/2026</a:t>
             </a:fld>
             <a:endParaRPr lang="en-US"/>
           </a:p>
@@ -564,10 +576,9 @@
           <a:lstStyle/>
           <a:p>
             <a:r>
-              <a:rPr lang="en-US" smtClean="0"/>
+              <a:rPr lang="en-US"/>
               <a:t>Click to edit Master title style</a:t>
             </a:r>
-            <a:endParaRPr lang="en-US"/>
           </a:p>
         </p:txBody>
       </p:sp>
@@ -593,38 +604,37 @@
           <a:p>
             <a:pPr lvl="0"/>
             <a:r>
-              <a:rPr lang="en-US" smtClean="0"/>
+              <a:rPr lang="en-US"/>
               <a:t>Click to edit Master text styles</a:t>
             </a:r>
           </a:p>
           <a:p>
             <a:pPr lvl="1"/>
             <a:r>
-              <a:rPr lang="en-US" smtClean="0"/>
+              <a:rPr lang="en-US"/>
               <a:t>Second level</a:t>
             </a:r>
           </a:p>
           <a:p>
             <a:pPr lvl="2"/>
             <a:r>
-              <a:rPr lang="en-US" smtClean="0"/>
+              <a:rPr lang="en-US"/>
               <a:t>Third level</a:t>
             </a:r>
           </a:p>
           <a:p>
             <a:pPr lvl="3"/>
             <a:r>
-              <a:rPr lang="en-US" smtClean="0"/>
+              <a:rPr lang="en-US"/>
               <a:t>Fourth level</a:t>
             </a:r>
           </a:p>
           <a:p>
             <a:pPr lvl="4"/>
             <a:r>
-              <a:rPr lang="en-US" smtClean="0"/>
+              <a:rPr lang="en-US"/>
               <a:t>Fifth level</a:t>
             </a:r>
-            <a:endParaRPr lang="en-US"/>
           </a:p>
         </p:txBody>
       </p:sp>
@@ -645,7 +655,7 @@
           <a:p>
             <a:fld id="{5BCAD085-E8A6-8845-BD4E-CB4CCA059FC4}" type="datetimeFigureOut">
               <a:rPr lang="en-US" smtClean="0"/>
-              <a:t>1/27/13</a:t>
+              <a:t>7/21/2026</a:t>
             </a:fld>
             <a:endParaRPr lang="en-US"/>
           </a:p>
@@ -739,10 +749,9 @@
           <a:lstStyle/>
           <a:p>
             <a:r>
-              <a:rPr lang="en-US" smtClean="0"/>
+              <a:rPr lang="en-US"/>
               <a:t>Click to edit Master title style</a:t>
             </a:r>
-            <a:endParaRPr lang="en-US"/>
           </a:p>
         </p:txBody>
       </p:sp>
@@ -763,38 +772,37 @@
           <a:p>
             <a:pPr lvl="0"/>
             <a:r>
-              <a:rPr lang="en-US" smtClean="0"/>
+              <a:rPr lang="en-US"/>
               <a:t>Click to edit Master text styles</a:t>
             </a:r>
           </a:p>
           <a:p>
             <a:pPr lvl="1"/>
             <a:r>
-              <a:rPr lang="en-US" smtClean="0"/>
+              <a:rPr lang="en-US"/>
               <a:t>Second level</a:t>
             </a:r>
           </a:p>
           <a:p>
             <a:pPr lvl="2"/>
             <a:r>
-              <a:rPr lang="en-US" smtClean="0"/>
+              <a:rPr lang="en-US"/>
               <a:t>Third level</a:t>
             </a:r>
           </a:p>
           <a:p>
             <a:pPr lvl="3"/>
             <a:r>
-              <a:rPr lang="en-US" smtClean="0"/>
+              <a:rPr lang="en-US"/>
               <a:t>Fourth level</a:t>
             </a:r>
           </a:p>
           <a:p>
             <a:pPr lvl="4"/>
             <a:r>
-              <a:rPr lang="en-US" smtClean="0"/>
+              <a:rPr lang="en-US"/>
               <a:t>Fifth level</a:t>
             </a:r>
-            <a:endParaRPr lang="en-US"/>
           </a:p>
         </p:txBody>
       </p:sp>
@@ -815,7 +823,7 @@
           <a:p>
             <a:fld id="{5BCAD085-E8A6-8845-BD4E-CB4CCA059FC4}" type="datetimeFigureOut">
               <a:rPr lang="en-US" smtClean="0"/>
-              <a:t>1/27/13</a:t>
+              <a:t>7/21/2026</a:t>
             </a:fld>
             <a:endParaRPr lang="en-US"/>
           </a:p>
@@ -918,10 +926,9 @@
           </a:lstStyle>
           <a:p>
             <a:r>
-              <a:rPr lang="en-US" smtClean="0"/>
+              <a:rPr lang="en-US"/>
               <a:t>Click to edit Master title style</a:t>
             </a:r>
-            <a:endParaRPr lang="en-US"/>
           </a:p>
         </p:txBody>
       </p:sp>
@@ -1038,7 +1045,7 @@
           <a:p>
             <a:pPr lvl="0"/>
             <a:r>
-              <a:rPr lang="en-US" smtClean="0"/>
+              <a:rPr lang="en-US"/>
               <a:t>Click to edit Master text styles</a:t>
             </a:r>
           </a:p>
@@ -1061,7 +1068,7 @@
           <a:p>
             <a:fld id="{5BCAD085-E8A6-8845-BD4E-CB4CCA059FC4}" type="datetimeFigureOut">
               <a:rPr lang="en-US" smtClean="0"/>
-              <a:t>1/27/13</a:t>
+              <a:t>7/21/2026</a:t>
             </a:fld>
             <a:endParaRPr lang="en-US"/>
           </a:p>
@@ -1155,10 +1162,9 @@
           <a:lstStyle/>
           <a:p>
             <a:r>
-              <a:rPr lang="en-US" smtClean="0"/>
+              <a:rPr lang="en-US"/>
               <a:t>Click to edit Master title style</a:t>
             </a:r>
-            <a:endParaRPr lang="en-US"/>
           </a:p>
         </p:txBody>
       </p:sp>
@@ -1212,38 +1218,37 @@
           <a:p>
             <a:pPr lvl="0"/>
             <a:r>
-              <a:rPr lang="en-US" smtClean="0"/>
+              <a:rPr lang="en-US"/>
               <a:t>Click to edit Master text styles</a:t>
             </a:r>
           </a:p>
           <a:p>
             <a:pPr lvl="1"/>
             <a:r>
-              <a:rPr lang="en-US" smtClean="0"/>
+              <a:rPr lang="en-US"/>
               <a:t>Second level</a:t>
             </a:r>
           </a:p>
           <a:p>
             <a:pPr lvl="2"/>
             <a:r>
-              <a:rPr lang="en-US" smtClean="0"/>
+              <a:rPr lang="en-US"/>
               <a:t>Third level</a:t>
             </a:r>
           </a:p>
           <a:p>
             <a:pPr lvl="3"/>
             <a:r>
-              <a:rPr lang="en-US" smtClean="0"/>
+              <a:rPr lang="en-US"/>
               <a:t>Fourth level</a:t>
             </a:r>
           </a:p>
           <a:p>
             <a:pPr lvl="4"/>
             <a:r>
-              <a:rPr lang="en-US" smtClean="0"/>
+              <a:rPr lang="en-US"/>
               <a:t>Fifth level</a:t>
             </a:r>
-            <a:endParaRPr lang="en-US"/>
           </a:p>
         </p:txBody>
       </p:sp>
@@ -1297,38 +1302,37 @@
           <a:p>
             <a:pPr lvl="0"/>
             <a:r>
-              <a:rPr lang="en-US" smtClean="0"/>
+              <a:rPr lang="en-US"/>
               <a:t>Click to edit Master text styles</a:t>
             </a:r>
           </a:p>
           <a:p>
             <a:pPr lvl="1"/>
             <a:r>
-              <a:rPr lang="en-US" smtClean="0"/>
+              <a:rPr lang="en-US"/>
               <a:t>Second level</a:t>
             </a:r>
           </a:p>
           <a:p>
             <a:pPr lvl="2"/>
             <a:r>
-              <a:rPr lang="en-US" smtClean="0"/>
+              <a:rPr lang="en-US"/>
               <a:t>Third level</a:t>
             </a:r>
           </a:p>
           <a:p>
             <a:pPr lvl="3"/>
             <a:r>
-              <a:rPr lang="en-US" smtClean="0"/>
+              <a:rPr lang="en-US"/>
               <a:t>Fourth level</a:t>
             </a:r>
           </a:p>
           <a:p>
             <a:pPr lvl="4"/>
             <a:r>
-              <a:rPr lang="en-US" smtClean="0"/>
+              <a:rPr lang="en-US"/>
               <a:t>Fifth level</a:t>
             </a:r>
-            <a:endParaRPr lang="en-US"/>
           </a:p>
         </p:txBody>
       </p:sp>
@@ -1349,7 +1353,7 @@
           <a:p>
             <a:fld id="{5BCAD085-E8A6-8845-BD4E-CB4CCA059FC4}" type="datetimeFigureOut">
               <a:rPr lang="en-US" smtClean="0"/>
-              <a:t>1/27/13</a:t>
+              <a:t>7/21/2026</a:t>
             </a:fld>
             <a:endParaRPr lang="en-US"/>
           </a:p>
@@ -1447,10 +1451,9 @@
           </a:lstStyle>
           <a:p>
             <a:r>
-              <a:rPr lang="en-US" smtClean="0"/>
+              <a:rPr lang="en-US"/>
               <a:t>Click to edit Master title style</a:t>
             </a:r>
-            <a:endParaRPr lang="en-US"/>
           </a:p>
         </p:txBody>
       </p:sp>
@@ -1513,7 +1516,7 @@
           <a:p>
             <a:pPr lvl="0"/>
             <a:r>
-              <a:rPr lang="en-US" smtClean="0"/>
+              <a:rPr lang="en-US"/>
               <a:t>Click to edit Master text styles</a:t>
             </a:r>
           </a:p>
@@ -1569,38 +1572,37 @@
           <a:p>
             <a:pPr lvl="0"/>
             <a:r>
-              <a:rPr lang="en-US" smtClean="0"/>
+              <a:rPr lang="en-US"/>
               <a:t>Click to edit Master text styles</a:t>
             </a:r>
           </a:p>
           <a:p>
             <a:pPr lvl="1"/>
             <a:r>
-              <a:rPr lang="en-US" smtClean="0"/>
+              <a:rPr lang="en-US"/>
               <a:t>Second level</a:t>
             </a:r>
           </a:p>
           <a:p>
             <a:pPr lvl="2"/>
             <a:r>
-              <a:rPr lang="en-US" smtClean="0"/>
+              <a:rPr lang="en-US"/>
               <a:t>Third level</a:t>
             </a:r>
           </a:p>
           <a:p>
             <a:pPr lvl="3"/>
             <a:r>
-              <a:rPr lang="en-US" smtClean="0"/>
+              <a:rPr lang="en-US"/>
               <a:t>Fourth level</a:t>
             </a:r>
           </a:p>
           <a:p>
             <a:pPr lvl="4"/>
             <a:r>
-              <a:rPr lang="en-US" smtClean="0"/>
+              <a:rPr lang="en-US"/>
               <a:t>Fifth level</a:t>
             </a:r>
-            <a:endParaRPr lang="en-US"/>
           </a:p>
         </p:txBody>
       </p:sp>
@@ -1663,7 +1665,7 @@
           <a:p>
             <a:pPr lvl="0"/>
             <a:r>
-              <a:rPr lang="en-US" smtClean="0"/>
+              <a:rPr lang="en-US"/>
               <a:t>Click to edit Master text styles</a:t>
             </a:r>
           </a:p>
@@ -1719,38 +1721,37 @@
           <a:p>
             <a:pPr lvl="0"/>
             <a:r>
-              <a:rPr lang="en-US" smtClean="0"/>
+              <a:rPr lang="en-US"/>
               <a:t>Click to edit Master text styles</a:t>
             </a:r>
           </a:p>
           <a:p>
             <a:pPr lvl="1"/>
             <a:r>
-              <a:rPr lang="en-US" smtClean="0"/>
+              <a:rPr lang="en-US"/>
               <a:t>Second level</a:t>
             </a:r>
           </a:p>
           <a:p>
             <a:pPr lvl="2"/>
             <a:r>
-              <a:rPr lang="en-US" smtClean="0"/>
+              <a:rPr lang="en-US"/>
               <a:t>Third level</a:t>
             </a:r>
           </a:p>
           <a:p>
             <a:pPr lvl="3"/>
             <a:r>
-              <a:rPr lang="en-US" smtClean="0"/>
+              <a:rPr lang="en-US"/>
               <a:t>Fourth level</a:t>
             </a:r>
           </a:p>
           <a:p>
             <a:pPr lvl="4"/>
             <a:r>
-              <a:rPr lang="en-US" smtClean="0"/>
+              <a:rPr lang="en-US"/>
               <a:t>Fifth level</a:t>
             </a:r>
-            <a:endParaRPr lang="en-US"/>
           </a:p>
         </p:txBody>
       </p:sp>
@@ -1771,7 +1772,7 @@
           <a:p>
             <a:fld id="{5BCAD085-E8A6-8845-BD4E-CB4CCA059FC4}" type="datetimeFigureOut">
               <a:rPr lang="en-US" smtClean="0"/>
-              <a:t>1/27/13</a:t>
+              <a:t>7/21/2026</a:t>
             </a:fld>
             <a:endParaRPr lang="en-US"/>
           </a:p>
@@ -1865,10 +1866,9 @@
           <a:lstStyle/>
           <a:p>
             <a:r>
-              <a:rPr lang="en-US" smtClean="0"/>
+              <a:rPr lang="en-US"/>
               <a:t>Click to edit Master title style</a:t>
             </a:r>
-            <a:endParaRPr lang="en-US"/>
           </a:p>
         </p:txBody>
       </p:sp>
@@ -1889,7 +1889,7 @@
           <a:p>
             <a:fld id="{5BCAD085-E8A6-8845-BD4E-CB4CCA059FC4}" type="datetimeFigureOut">
               <a:rPr lang="en-US" smtClean="0"/>
-              <a:t>1/27/13</a:t>
+              <a:t>7/21/2026</a:t>
             </a:fld>
             <a:endParaRPr lang="en-US"/>
           </a:p>
@@ -1984,7 +1984,7 @@
           <a:p>
             <a:fld id="{5BCAD085-E8A6-8845-BD4E-CB4CCA059FC4}" type="datetimeFigureOut">
               <a:rPr lang="en-US" smtClean="0"/>
-              <a:t>1/27/13</a:t>
+              <a:t>7/21/2026</a:t>
             </a:fld>
             <a:endParaRPr lang="en-US"/>
           </a:p>
@@ -2087,10 +2087,9 @@
           </a:lstStyle>
           <a:p>
             <a:r>
-              <a:rPr lang="en-US" smtClean="0"/>
+              <a:rPr lang="en-US"/>
               <a:t>Click to edit Master title style</a:t>
             </a:r>
-            <a:endParaRPr lang="en-US"/>
           </a:p>
         </p:txBody>
       </p:sp>
@@ -2144,38 +2143,37 @@
           <a:p>
             <a:pPr lvl="0"/>
             <a:r>
-              <a:rPr lang="en-US" smtClean="0"/>
+              <a:rPr lang="en-US"/>
               <a:t>Click to edit Master text styles</a:t>
             </a:r>
           </a:p>
           <a:p>
             <a:pPr lvl="1"/>
             <a:r>
-              <a:rPr lang="en-US" smtClean="0"/>
+              <a:rPr lang="en-US"/>
               <a:t>Second level</a:t>
             </a:r>
           </a:p>
           <a:p>
             <a:pPr lvl="2"/>
             <a:r>
-              <a:rPr lang="en-US" smtClean="0"/>
+              <a:rPr lang="en-US"/>
               <a:t>Third level</a:t>
             </a:r>
           </a:p>
           <a:p>
             <a:pPr lvl="3"/>
             <a:r>
-              <a:rPr lang="en-US" smtClean="0"/>
+              <a:rPr lang="en-US"/>
               <a:t>Fourth level</a:t>
             </a:r>
           </a:p>
           <a:p>
             <a:pPr lvl="4"/>
             <a:r>
-              <a:rPr lang="en-US" smtClean="0"/>
+              <a:rPr lang="en-US"/>
               <a:t>Fifth level</a:t>
             </a:r>
-            <a:endParaRPr lang="en-US"/>
           </a:p>
         </p:txBody>
       </p:sp>
@@ -2238,7 +2236,7 @@
           <a:p>
             <a:pPr lvl="0"/>
             <a:r>
-              <a:rPr lang="en-US" smtClean="0"/>
+              <a:rPr lang="en-US"/>
               <a:t>Click to edit Master text styles</a:t>
             </a:r>
           </a:p>
@@ -2261,7 +2259,7 @@
           <a:p>
             <a:fld id="{5BCAD085-E8A6-8845-BD4E-CB4CCA059FC4}" type="datetimeFigureOut">
               <a:rPr lang="en-US" smtClean="0"/>
-              <a:t>1/27/13</a:t>
+              <a:t>7/21/2026</a:t>
             </a:fld>
             <a:endParaRPr lang="en-US"/>
           </a:p>
@@ -2364,10 +2362,9 @@
           </a:lstStyle>
           <a:p>
             <a:r>
-              <a:rPr lang="en-US" smtClean="0"/>
+              <a:rPr lang="en-US"/>
               <a:t>Click to edit Master title style</a:t>
             </a:r>
-            <a:endParaRPr lang="en-US"/>
           </a:p>
         </p:txBody>
       </p:sp>
@@ -2491,7 +2488,7 @@
           <a:p>
             <a:pPr lvl="0"/>
             <a:r>
-              <a:rPr lang="en-US" smtClean="0"/>
+              <a:rPr lang="en-US"/>
               <a:t>Click to edit Master text styles</a:t>
             </a:r>
           </a:p>
@@ -2514,7 +2511,7 @@
           <a:p>
             <a:fld id="{5BCAD085-E8A6-8845-BD4E-CB4CCA059FC4}" type="datetimeFigureOut">
               <a:rPr lang="en-US" smtClean="0"/>
-              <a:t>1/27/13</a:t>
+              <a:t>7/21/2026</a:t>
             </a:fld>
             <a:endParaRPr lang="en-US"/>
           </a:p>
@@ -2623,10 +2620,9 @@
           <a:lstStyle/>
           <a:p>
             <a:r>
-              <a:rPr lang="en-US" smtClean="0"/>
+              <a:rPr lang="en-US"/>
               <a:t>Click to edit Master title style</a:t>
             </a:r>
-            <a:endParaRPr lang="en-US"/>
           </a:p>
         </p:txBody>
       </p:sp>
@@ -2657,38 +2653,37 @@
           <a:p>
             <a:pPr lvl="0"/>
             <a:r>
-              <a:rPr lang="en-US" smtClean="0"/>
+              <a:rPr lang="en-US"/>
               <a:t>Click to edit Master text styles</a:t>
             </a:r>
           </a:p>
           <a:p>
             <a:pPr lvl="1"/>
             <a:r>
-              <a:rPr lang="en-US" smtClean="0"/>
+              <a:rPr lang="en-US"/>
               <a:t>Second level</a:t>
             </a:r>
           </a:p>
           <a:p>
             <a:pPr lvl="2"/>
             <a:r>
-              <a:rPr lang="en-US" smtClean="0"/>
+              <a:rPr lang="en-US"/>
               <a:t>Third level</a:t>
             </a:r>
           </a:p>
           <a:p>
             <a:pPr lvl="3"/>
             <a:r>
-              <a:rPr lang="en-US" smtClean="0"/>
+              <a:rPr lang="en-US"/>
               <a:t>Fourth level</a:t>
             </a:r>
           </a:p>
           <a:p>
             <a:pPr lvl="4"/>
             <a:r>
-              <a:rPr lang="en-US" smtClean="0"/>
+              <a:rPr lang="en-US"/>
               <a:t>Fifth level</a:t>
             </a:r>
-            <a:endParaRPr lang="en-US"/>
           </a:p>
         </p:txBody>
       </p:sp>
@@ -2727,7 +2722,7 @@
           <a:p>
             <a:fld id="{5BCAD085-E8A6-8845-BD4E-CB4CCA059FC4}" type="datetimeFigureOut">
               <a:rPr lang="en-US" smtClean="0"/>
-              <a:t>1/27/13</a:t>
+              <a:t>7/21/2026</a:t>
             </a:fld>
             <a:endParaRPr lang="en-US"/>
           </a:p>
@@ -3086,7 +3081,7 @@
 </file>
 
 <file path=ppt/slides/slide1.xml><?xml version="1.0" encoding="utf-8"?>
-<p:sld xmlns:a="http://schemas.openxmlformats.org/drawingml/2006/main" xmlns:p="http://schemas.openxmlformats.org/presentationml/2006/main" xmlns:r="http://schemas.openxmlformats.org/officeDocument/2006/relationships">
+<p:sld xmlns:a="http://schemas.openxmlformats.org/drawingml/2006/main" xmlns:r="http://schemas.openxmlformats.org/officeDocument/2006/relationships" xmlns:p="http://schemas.openxmlformats.org/presentationml/2006/main">
   <p:cSld>
     <p:spTree>
       <p:nvGrpSpPr>
@@ -3094,7 +3089,14 @@
         <p:cNvGrpSpPr/>
         <p:nvPr/>
       </p:nvGrpSpPr>
-      <p:grpSpPr/>
+      <p:grpSpPr>
+        <a:xfrm>
+          <a:off x="0" y="0"/>
+          <a:ext cx="0" cy="0"/>
+          <a:chOff x="0" y="0"/>
+          <a:chExt cx="0" cy="0"/>
+        </a:xfrm>
+      </p:grpSpPr>
       <p:sp>
         <p:nvSpPr>
           <p:cNvPr id="2" name="Rectangle 1"/>
@@ -3135,6 +3137,7 @@
           <a:lstStyle/>
           <a:p>
             <a:pPr algn="ctr"/>
+            <a:endParaRPr/>
           </a:p>
         </p:txBody>
       </p:sp>
@@ -3180,6 +3183,7 @@
           <a:lstStyle/>
           <a:p>
             <a:pPr algn="ctr"/>
+            <a:endParaRPr/>
           </a:p>
         </p:txBody>
       </p:sp>
@@ -3289,7 +3293,77 @@
       </p:sp>
       <p:sp>
         <p:nvSpPr>
-          <p:cNvPr id="6" name="TextBox 5"/>
+          <p:cNvPr id="6" name="Rounded Rectangle 5"/>
+          <p:cNvSpPr/>
+          <p:nvPr/>
+        </p:nvSpPr>
+        <p:spPr>
+          <a:xfrm>
+            <a:off x="8869680" y="777240"/>
+            <a:ext cx="2194560" cy="2057400"/>
+          </a:xfrm>
+          <a:prstGeom prst="roundRect">
+            <a:avLst/>
+          </a:prstGeom>
+          <a:solidFill>
+            <a:srgbClr val="FFFFFF"/>
+          </a:solidFill>
+          <a:ln w="15240">
+            <a:solidFill>
+              <a:srgbClr val="2DD4BF"/>
+            </a:solidFill>
+          </a:ln>
+        </p:spPr>
+        <p:style>
+          <a:lnRef idx="1">
+            <a:schemeClr val="accent1"/>
+          </a:lnRef>
+          <a:fillRef idx="3">
+            <a:schemeClr val="accent1"/>
+          </a:fillRef>
+          <a:effectRef idx="2">
+            <a:schemeClr val="accent1"/>
+          </a:effectRef>
+          <a:fontRef idx="minor">
+            <a:schemeClr val="lt1"/>
+          </a:fontRef>
+        </p:style>
+        <p:txBody>
+          <a:bodyPr rtlCol="0" anchor="ctr"/>
+          <a:lstStyle/>
+          <a:p>
+            <a:pPr algn="ctr"/>
+            <a:endParaRPr/>
+          </a:p>
+        </p:txBody>
+      </p:sp>
+      <p:pic>
+        <p:nvPicPr>
+          <p:cNvPr id="7" name="Picture 6" descr="UNITOMO.jpg"/>
+          <p:cNvPicPr>
+            <a:picLocks noChangeAspect="1"/>
+          </p:cNvPicPr>
+          <p:nvPr/>
+        </p:nvPicPr>
+        <p:blipFill>
+          <a:blip r:embed="rId2"/>
+          <a:stretch>
+            <a:fillRect/>
+          </a:stretch>
+        </p:blipFill>
+        <p:spPr>
+          <a:xfrm>
+            <a:off x="9047181" y="914400"/>
+            <a:ext cx="1839557" cy="1783080"/>
+          </a:xfrm>
+          <a:prstGeom prst="rect">
+            <a:avLst/>
+          </a:prstGeom>
+        </p:spPr>
+      </p:pic>
+      <p:sp>
+        <p:nvSpPr>
+          <p:cNvPr id="8" name="TextBox 7"/>
           <p:cNvSpPr txBox="1"/>
           <p:nvPr/>
         </p:nvSpPr>
@@ -3324,7 +3398,7 @@
       </p:sp>
       <p:sp>
         <p:nvSpPr>
-          <p:cNvPr id="7" name="Rectangle 6"/>
+          <p:cNvPr id="9" name="Rectangle 8"/>
           <p:cNvSpPr/>
           <p:nvPr/>
         </p:nvSpPr>
@@ -3362,12 +3436,13 @@
           <a:lstStyle/>
           <a:p>
             <a:pPr algn="ctr"/>
-          </a:p>
-        </p:txBody>
-      </p:sp>
-      <p:sp>
-        <p:nvSpPr>
-          <p:cNvPr id="8" name="TextBox 7"/>
+            <a:endParaRPr/>
+          </a:p>
+        </p:txBody>
+      </p:sp>
+      <p:sp>
+        <p:nvSpPr>
+          <p:cNvPr id="10" name="TextBox 9"/>
           <p:cNvSpPr txBox="1"/>
           <p:nvPr/>
         </p:nvSpPr>
@@ -3402,7 +3477,7 @@
       </p:sp>
       <p:sp>
         <p:nvSpPr>
-          <p:cNvPr id="9" name="Rounded Rectangle 8"/>
+          <p:cNvPr id="11" name="Rounded Rectangle 10"/>
           <p:cNvSpPr/>
           <p:nvPr/>
         </p:nvSpPr>
@@ -3442,19 +3517,20 @@
           <a:lstStyle/>
           <a:p>
             <a:pPr algn="ctr"/>
-          </a:p>
-        </p:txBody>
-      </p:sp>
-      <p:sp>
-        <p:nvSpPr>
-          <p:cNvPr id="10" name="TextBox 9"/>
+            <a:endParaRPr/>
+          </a:p>
+        </p:txBody>
+      </p:sp>
+      <p:sp>
+        <p:nvSpPr>
+          <p:cNvPr id="12" name="TextBox 11"/>
           <p:cNvSpPr txBox="1"/>
           <p:nvPr/>
         </p:nvSpPr>
         <p:spPr>
           <a:xfrm>
-            <a:off x="1280160" y="3657600"/>
-            <a:ext cx="2779776" cy="2011680"/>
+            <a:off x="1280160" y="4253736"/>
+            <a:ext cx="2779776" cy="1036181"/>
           </a:xfrm>
           <a:prstGeom prst="rect">
             <a:avLst/>
@@ -3475,6 +3551,7 @@
               </a:defRPr>
             </a:pPr>
             <a:r>
+              <a:rPr dirty="0"/>
               <a:t>Fahri Adis Al Hafni</a:t>
             </a:r>
           </a:p>
@@ -3490,6 +3567,7 @@
               </a:defRPr>
             </a:pPr>
             <a:r>
+              <a:rPr dirty="0"/>
               <a:t>NIM: 202511420105</a:t>
             </a:r>
           </a:p>
@@ -3504,19 +3582,16 @@
                 </a:solidFill>
               </a:defRPr>
             </a:pPr>
-            <a:r>
-              <a:t>Peran Utama:</a:t>
-            </a:r>
-            <a:br/>
-            <a:r>
-              <a:t>Fullstack Developer &amp; DB Designer</a:t>
-            </a:r>
-          </a:p>
-        </p:txBody>
-      </p:sp>
-      <p:sp>
-        <p:nvSpPr>
-          <p:cNvPr id="11" name="Rounded Rectangle 10"/>
+            <a:br>
+              <a:rPr dirty="0"/>
+            </a:br>
+            <a:endParaRPr dirty="0"/>
+          </a:p>
+        </p:txBody>
+      </p:sp>
+      <p:sp>
+        <p:nvSpPr>
+          <p:cNvPr id="13" name="Rounded Rectangle 12"/>
           <p:cNvSpPr/>
           <p:nvPr/>
         </p:nvSpPr>
@@ -3556,19 +3631,20 @@
           <a:lstStyle/>
           <a:p>
             <a:pPr algn="ctr"/>
-          </a:p>
-        </p:txBody>
-      </p:sp>
-      <p:sp>
-        <p:nvSpPr>
-          <p:cNvPr id="12" name="TextBox 11"/>
+            <a:endParaRPr/>
+          </a:p>
+        </p:txBody>
+      </p:sp>
+      <p:sp>
+        <p:nvSpPr>
+          <p:cNvPr id="14" name="TextBox 13"/>
           <p:cNvSpPr txBox="1"/>
           <p:nvPr/>
         </p:nvSpPr>
         <p:spPr>
           <a:xfrm>
-            <a:off x="4700016" y="3657600"/>
-            <a:ext cx="2779776" cy="2011680"/>
+            <a:off x="4700016" y="4260329"/>
+            <a:ext cx="2779776" cy="866904"/>
           </a:xfrm>
           <a:prstGeom prst="rect">
             <a:avLst/>
@@ -3589,8 +3665,18 @@
               </a:defRPr>
             </a:pPr>
             <a:r>
-              <a:t>Sahrul Mubarok</a:t>
-            </a:r>
+              <a:rPr dirty="0" err="1"/>
+              <a:t>Sahrul</a:t>
+            </a:r>
+            <a:r>
+              <a:rPr dirty="0"/>
+              <a:t> </a:t>
+            </a:r>
+            <a:r>
+              <a:rPr dirty="0" err="1"/>
+              <a:t>Mubarok</a:t>
+            </a:r>
+            <a:endParaRPr dirty="0"/>
           </a:p>
           <a:p>
             <a:pPr>
@@ -3604,6 +3690,7 @@
               </a:defRPr>
             </a:pPr>
             <a:r>
+              <a:rPr dirty="0"/>
               <a:t>NIM: 202511420107</a:t>
             </a:r>
           </a:p>
@@ -3618,19 +3705,13 @@
                 </a:solidFill>
               </a:defRPr>
             </a:pPr>
-            <a:r>
-              <a:t>Peran Utama:</a:t>
-            </a:r>
-            <a:br/>
-            <a:r>
-              <a:t>Backend &amp; Cloud Infrastructure</a:t>
-            </a:r>
-          </a:p>
-        </p:txBody>
-      </p:sp>
-      <p:sp>
-        <p:nvSpPr>
-          <p:cNvPr id="13" name="Rounded Rectangle 12"/>
+            <a:endParaRPr dirty="0"/>
+          </a:p>
+        </p:txBody>
+      </p:sp>
+      <p:sp>
+        <p:nvSpPr>
+          <p:cNvPr id="15" name="Rounded Rectangle 14"/>
           <p:cNvSpPr/>
           <p:nvPr/>
         </p:nvSpPr>
@@ -3670,19 +3751,20 @@
           <a:lstStyle/>
           <a:p>
             <a:pPr algn="ctr"/>
-          </a:p>
-        </p:txBody>
-      </p:sp>
-      <p:sp>
-        <p:nvSpPr>
-          <p:cNvPr id="14" name="TextBox 13"/>
+            <a:endParaRPr/>
+          </a:p>
+        </p:txBody>
+      </p:sp>
+      <p:sp>
+        <p:nvSpPr>
+          <p:cNvPr id="16" name="TextBox 15"/>
           <p:cNvSpPr txBox="1"/>
           <p:nvPr/>
         </p:nvSpPr>
         <p:spPr>
           <a:xfrm>
-            <a:off x="8119872" y="3657600"/>
-            <a:ext cx="2779776" cy="2011680"/>
+            <a:off x="8159191" y="4253736"/>
+            <a:ext cx="2779776" cy="866904"/>
           </a:xfrm>
           <a:prstGeom prst="rect">
             <a:avLst/>
@@ -3703,6 +3785,7 @@
               </a:defRPr>
             </a:pPr>
             <a:r>
+              <a:rPr dirty="0"/>
               <a:t>Ach Tohir</a:t>
             </a:r>
           </a:p>
@@ -3718,6 +3801,7 @@
               </a:defRPr>
             </a:pPr>
             <a:r>
+              <a:rPr dirty="0"/>
               <a:t>NIM: 202511420048</a:t>
             </a:r>
           </a:p>
@@ -3732,13 +3816,7 @@
                 </a:solidFill>
               </a:defRPr>
             </a:pPr>
-            <a:r>
-              <a:t>Peran Utama:</a:t>
-            </a:r>
-            <a:br/>
-            <a:r>
-              <a:t>Frontend UI/UX &amp; QA Tester</a:t>
-            </a:r>
+            <a:endParaRPr dirty="0"/>
           </a:p>
         </p:txBody>
       </p:sp>
@@ -3751,7 +3829,7 @@
 </file>
 
 <file path=ppt/slides/slide2.xml><?xml version="1.0" encoding="utf-8"?>
-<p:sld xmlns:a="http://schemas.openxmlformats.org/drawingml/2006/main" xmlns:p="http://schemas.openxmlformats.org/presentationml/2006/main" xmlns:r="http://schemas.openxmlformats.org/officeDocument/2006/relationships">
+<p:sld xmlns:a="http://schemas.openxmlformats.org/drawingml/2006/main" xmlns:r="http://schemas.openxmlformats.org/officeDocument/2006/relationships" xmlns:p="http://schemas.openxmlformats.org/presentationml/2006/main">
   <p:cSld>
     <p:spTree>
       <p:nvGrpSpPr>
@@ -3759,7 +3837,14 @@
         <p:cNvGrpSpPr/>
         <p:nvPr/>
       </p:nvGrpSpPr>
-      <p:grpSpPr/>
+      <p:grpSpPr>
+        <a:xfrm>
+          <a:off x="0" y="0"/>
+          <a:ext cx="0" cy="0"/>
+          <a:chOff x="0" y="0"/>
+          <a:chExt cx="0" cy="0"/>
+        </a:xfrm>
+      </p:grpSpPr>
       <p:sp>
         <p:nvSpPr>
           <p:cNvPr id="2" name="Rectangle 1"/>
@@ -3800,6 +3885,7 @@
           <a:lstStyle/>
           <a:p>
             <a:pPr algn="ctr"/>
+            <a:endParaRPr/>
           </a:p>
         </p:txBody>
       </p:sp>
@@ -3820,7 +3906,7 @@
           <a:noFill/>
         </p:spPr>
         <p:txBody>
-          <a:bodyPr wrap="square" lIns="0" rIns="0" tIns="0" bIns="0">
+          <a:bodyPr wrap="square" lIns="0" tIns="0" rIns="0" bIns="0">
             <a:spAutoFit/>
           </a:bodyPr>
           <a:lstStyle/>
@@ -3855,7 +3941,7 @@
           <a:noFill/>
         </p:spPr>
         <p:txBody>
-          <a:bodyPr wrap="square" lIns="0" rIns="0" tIns="0" bIns="0">
+          <a:bodyPr wrap="square" lIns="0" tIns="0" rIns="0" bIns="0">
             <a:spAutoFit/>
           </a:bodyPr>
           <a:lstStyle/>
@@ -3913,6 +3999,7 @@
           <a:lstStyle/>
           <a:p>
             <a:pPr algn="ctr"/>
+            <a:endParaRPr/>
           </a:p>
         </p:txBody>
       </p:sp>
@@ -3933,7 +4020,7 @@
           <a:noFill/>
         </p:spPr>
         <p:txBody>
-          <a:bodyPr wrap="none" lIns="0" rIns="0" tIns="0" bIns="0">
+          <a:bodyPr wrap="none" lIns="0" tIns="0" rIns="0" bIns="0">
             <a:spAutoFit/>
           </a:bodyPr>
           <a:lstStyle/>
@@ -4005,6 +4092,7 @@
           <a:lstStyle/>
           <a:p>
             <a:pPr algn="ctr"/>
+            <a:endParaRPr/>
           </a:p>
         </p:txBody>
       </p:sp>
@@ -4100,6 +4188,7 @@
           <a:lstStyle/>
           <a:p>
             <a:pPr algn="ctr"/>
+            <a:endParaRPr/>
           </a:p>
         </p:txBody>
       </p:sp>
@@ -4195,6 +4284,7 @@
           <a:lstStyle/>
           <a:p>
             <a:pPr algn="ctr"/>
+            <a:endParaRPr/>
           </a:p>
         </p:txBody>
       </p:sp>
@@ -4290,6 +4380,7 @@
           <a:lstStyle/>
           <a:p>
             <a:pPr algn="ctr"/>
+            <a:endParaRPr/>
           </a:p>
         </p:txBody>
       </p:sp>
@@ -4385,6 +4476,7 @@
           <a:lstStyle/>
           <a:p>
             <a:pPr algn="ctr"/>
+            <a:endParaRPr/>
           </a:p>
         </p:txBody>
       </p:sp>
@@ -4432,7 +4524,7 @@
 </file>
 
 <file path=ppt/slides/slide3.xml><?xml version="1.0" encoding="utf-8"?>
-<p:sld xmlns:a="http://schemas.openxmlformats.org/drawingml/2006/main" xmlns:p="http://schemas.openxmlformats.org/presentationml/2006/main" xmlns:r="http://schemas.openxmlformats.org/officeDocument/2006/relationships">
+<p:sld xmlns:a="http://schemas.openxmlformats.org/drawingml/2006/main" xmlns:r="http://schemas.openxmlformats.org/officeDocument/2006/relationships" xmlns:p="http://schemas.openxmlformats.org/presentationml/2006/main">
   <p:cSld>
     <p:spTree>
       <p:nvGrpSpPr>
@@ -4440,7 +4532,14 @@
         <p:cNvGrpSpPr/>
         <p:nvPr/>
       </p:nvGrpSpPr>
-      <p:grpSpPr/>
+      <p:grpSpPr>
+        <a:xfrm>
+          <a:off x="0" y="0"/>
+          <a:ext cx="0" cy="0"/>
+          <a:chOff x="0" y="0"/>
+          <a:chExt cx="0" cy="0"/>
+        </a:xfrm>
+      </p:grpSpPr>
       <p:sp>
         <p:nvSpPr>
           <p:cNvPr id="2" name="Rectangle 1"/>
@@ -4481,6 +4580,7 @@
           <a:lstStyle/>
           <a:p>
             <a:pPr algn="ctr"/>
+            <a:endParaRPr/>
           </a:p>
         </p:txBody>
       </p:sp>
@@ -4501,7 +4601,7 @@
           <a:noFill/>
         </p:spPr>
         <p:txBody>
-          <a:bodyPr wrap="square" lIns="0" rIns="0" tIns="0" bIns="0">
+          <a:bodyPr wrap="square" lIns="0" tIns="0" rIns="0" bIns="0">
             <a:spAutoFit/>
           </a:bodyPr>
           <a:lstStyle/>
@@ -4536,7 +4636,7 @@
           <a:noFill/>
         </p:spPr>
         <p:txBody>
-          <a:bodyPr wrap="square" lIns="0" rIns="0" tIns="0" bIns="0">
+          <a:bodyPr wrap="square" lIns="0" tIns="0" rIns="0" bIns="0">
             <a:spAutoFit/>
           </a:bodyPr>
           <a:lstStyle/>
@@ -4594,6 +4694,7 @@
           <a:lstStyle/>
           <a:p>
             <a:pPr algn="ctr"/>
+            <a:endParaRPr/>
           </a:p>
         </p:txBody>
       </p:sp>
@@ -4614,7 +4715,7 @@
           <a:noFill/>
         </p:spPr>
         <p:txBody>
-          <a:bodyPr wrap="none" lIns="0" rIns="0" tIns="0" bIns="0">
+          <a:bodyPr wrap="none" lIns="0" tIns="0" rIns="0" bIns="0">
             <a:spAutoFit/>
           </a:bodyPr>
           <a:lstStyle/>
@@ -4686,6 +4787,7 @@
           <a:lstStyle/>
           <a:p>
             <a:pPr algn="ctr"/>
+            <a:endParaRPr/>
           </a:p>
         </p:txBody>
       </p:sp>
@@ -4841,6 +4943,7 @@
           <a:lstStyle/>
           <a:p>
             <a:pPr algn="ctr"/>
+            <a:endParaRPr/>
           </a:p>
         </p:txBody>
       </p:sp>
@@ -4951,6 +5054,7 @@
           <a:lstStyle/>
           <a:p>
             <a:pPr algn="ctr"/>
+            <a:endParaRPr/>
           </a:p>
         </p:txBody>
       </p:sp>
@@ -5061,6 +5165,7 @@
           <a:lstStyle/>
           <a:p>
             <a:pPr algn="ctr"/>
+            <a:endParaRPr/>
           </a:p>
         </p:txBody>
       </p:sp>
@@ -5171,6 +5276,7 @@
           <a:lstStyle/>
           <a:p>
             <a:pPr algn="ctr"/>
+            <a:endParaRPr/>
           </a:p>
         </p:txBody>
       </p:sp>
@@ -5248,7 +5354,7 @@
 </file>
 
 <file path=ppt/slides/slide4.xml><?xml version="1.0" encoding="utf-8"?>
-<p:sld xmlns:a="http://schemas.openxmlformats.org/drawingml/2006/main" xmlns:p="http://schemas.openxmlformats.org/presentationml/2006/main" xmlns:r="http://schemas.openxmlformats.org/officeDocument/2006/relationships">
+<p:sld xmlns:a="http://schemas.openxmlformats.org/drawingml/2006/main" xmlns:r="http://schemas.openxmlformats.org/officeDocument/2006/relationships" xmlns:p="http://schemas.openxmlformats.org/presentationml/2006/main">
   <p:cSld>
     <p:spTree>
       <p:nvGrpSpPr>
@@ -5256,7 +5362,14 @@
         <p:cNvGrpSpPr/>
         <p:nvPr/>
       </p:nvGrpSpPr>
-      <p:grpSpPr/>
+      <p:grpSpPr>
+        <a:xfrm>
+          <a:off x="0" y="0"/>
+          <a:ext cx="0" cy="0"/>
+          <a:chOff x="0" y="0"/>
+          <a:chExt cx="0" cy="0"/>
+        </a:xfrm>
+      </p:grpSpPr>
       <p:sp>
         <p:nvSpPr>
           <p:cNvPr id="2" name="Rectangle 1"/>
@@ -5297,6 +5410,7 @@
           <a:lstStyle/>
           <a:p>
             <a:pPr algn="ctr"/>
+            <a:endParaRPr/>
           </a:p>
         </p:txBody>
       </p:sp>
@@ -5317,7 +5431,7 @@
           <a:noFill/>
         </p:spPr>
         <p:txBody>
-          <a:bodyPr wrap="square" lIns="0" rIns="0" tIns="0" bIns="0">
+          <a:bodyPr wrap="square" lIns="0" tIns="0" rIns="0" bIns="0">
             <a:spAutoFit/>
           </a:bodyPr>
           <a:lstStyle/>
@@ -5352,7 +5466,7 @@
           <a:noFill/>
         </p:spPr>
         <p:txBody>
-          <a:bodyPr wrap="square" lIns="0" rIns="0" tIns="0" bIns="0">
+          <a:bodyPr wrap="square" lIns="0" tIns="0" rIns="0" bIns="0">
             <a:spAutoFit/>
           </a:bodyPr>
           <a:lstStyle/>
@@ -5410,6 +5524,7 @@
           <a:lstStyle/>
           <a:p>
             <a:pPr algn="ctr"/>
+            <a:endParaRPr/>
           </a:p>
         </p:txBody>
       </p:sp>
@@ -5430,7 +5545,7 @@
           <a:noFill/>
         </p:spPr>
         <p:txBody>
-          <a:bodyPr wrap="none" lIns="0" rIns="0" tIns="0" bIns="0">
+          <a:bodyPr wrap="none" lIns="0" tIns="0" rIns="0" bIns="0">
             <a:spAutoFit/>
           </a:bodyPr>
           <a:lstStyle/>
@@ -5502,6 +5617,7 @@
           <a:lstStyle/>
           <a:p>
             <a:pPr algn="ctr"/>
+            <a:endParaRPr/>
           </a:p>
         </p:txBody>
       </p:sp>
@@ -5606,6 +5722,7 @@
           <a:lstStyle/>
           <a:p>
             <a:pPr algn="ctr"/>
+            <a:endParaRPr/>
           </a:p>
         </p:txBody>
       </p:sp>
@@ -5710,6 +5827,7 @@
           <a:lstStyle/>
           <a:p>
             <a:pPr algn="ctr"/>
+            <a:endParaRPr/>
           </a:p>
         </p:txBody>
       </p:sp>
@@ -5814,6 +5932,7 @@
           <a:lstStyle/>
           <a:p>
             <a:pPr algn="ctr"/>
+            <a:endParaRPr/>
           </a:p>
         </p:txBody>
       </p:sp>
@@ -5918,6 +6037,7 @@
           <a:lstStyle/>
           <a:p>
             <a:pPr algn="ctr"/>
+            <a:endParaRPr/>
           </a:p>
         </p:txBody>
       </p:sp>
@@ -6058,6 +6178,7 @@
           <a:lstStyle/>
           <a:p>
             <a:pPr algn="ctr"/>
+            <a:endParaRPr/>
           </a:p>
         </p:txBody>
       </p:sp>
@@ -6165,7 +6286,7 @@
 </file>
 
 <file path=ppt/slides/slide5.xml><?xml version="1.0" encoding="utf-8"?>
-<p:sld xmlns:a="http://schemas.openxmlformats.org/drawingml/2006/main" xmlns:p="http://schemas.openxmlformats.org/presentationml/2006/main" xmlns:r="http://schemas.openxmlformats.org/officeDocument/2006/relationships">
+<p:sld xmlns:a="http://schemas.openxmlformats.org/drawingml/2006/main" xmlns:r="http://schemas.openxmlformats.org/officeDocument/2006/relationships" xmlns:p="http://schemas.openxmlformats.org/presentationml/2006/main">
   <p:cSld>
     <p:spTree>
       <p:nvGrpSpPr>
@@ -6173,7 +6294,14 @@
         <p:cNvGrpSpPr/>
         <p:nvPr/>
       </p:nvGrpSpPr>
-      <p:grpSpPr/>
+      <p:grpSpPr>
+        <a:xfrm>
+          <a:off x="0" y="0"/>
+          <a:ext cx="0" cy="0"/>
+          <a:chOff x="0" y="0"/>
+          <a:chExt cx="0" cy="0"/>
+        </a:xfrm>
+      </p:grpSpPr>
       <p:sp>
         <p:nvSpPr>
           <p:cNvPr id="2" name="Rectangle 1"/>
@@ -6214,6 +6342,7 @@
           <a:lstStyle/>
           <a:p>
             <a:pPr algn="ctr"/>
+            <a:endParaRPr/>
           </a:p>
         </p:txBody>
       </p:sp>
@@ -6234,7 +6363,7 @@
           <a:noFill/>
         </p:spPr>
         <p:txBody>
-          <a:bodyPr wrap="square" lIns="0" rIns="0" tIns="0" bIns="0">
+          <a:bodyPr wrap="square" lIns="0" tIns="0" rIns="0" bIns="0">
             <a:spAutoFit/>
           </a:bodyPr>
           <a:lstStyle/>
@@ -6269,7 +6398,7 @@
           <a:noFill/>
         </p:spPr>
         <p:txBody>
-          <a:bodyPr wrap="square" lIns="0" rIns="0" tIns="0" bIns="0">
+          <a:bodyPr wrap="square" lIns="0" tIns="0" rIns="0" bIns="0">
             <a:spAutoFit/>
           </a:bodyPr>
           <a:lstStyle/>
@@ -6327,6 +6456,7 @@
           <a:lstStyle/>
           <a:p>
             <a:pPr algn="ctr"/>
+            <a:endParaRPr/>
           </a:p>
         </p:txBody>
       </p:sp>
@@ -6347,7 +6477,7 @@
           <a:noFill/>
         </p:spPr>
         <p:txBody>
-          <a:bodyPr wrap="none" lIns="0" rIns="0" tIns="0" bIns="0">
+          <a:bodyPr wrap="none" lIns="0" tIns="0" rIns="0" bIns="0">
             <a:spAutoFit/>
           </a:bodyPr>
           <a:lstStyle/>
@@ -6419,6 +6549,7 @@
           <a:lstStyle/>
           <a:p>
             <a:pPr algn="ctr"/>
+            <a:endParaRPr/>
           </a:p>
         </p:txBody>
       </p:sp>
@@ -6497,6 +6628,7 @@
           <a:lstStyle/>
           <a:p>
             <a:pPr algn="ctr"/>
+            <a:endParaRPr/>
           </a:p>
         </p:txBody>
       </p:sp>
@@ -6601,6 +6733,7 @@
           <a:lstStyle/>
           <a:p>
             <a:pPr algn="ctr"/>
+            <a:endParaRPr/>
           </a:p>
         </p:txBody>
       </p:sp>
@@ -6679,6 +6812,7 @@
           <a:lstStyle/>
           <a:p>
             <a:pPr algn="ctr"/>
+            <a:endParaRPr/>
           </a:p>
         </p:txBody>
       </p:sp>
@@ -6783,6 +6917,7 @@
           <a:lstStyle/>
           <a:p>
             <a:pPr algn="ctr"/>
+            <a:endParaRPr/>
           </a:p>
         </p:txBody>
       </p:sp>
@@ -6861,12 +6996,54 @@
           <a:lstStyle/>
           <a:p>
             <a:pPr algn="ctr"/>
+            <a:endParaRPr/>
+          </a:p>
+        </p:txBody>
+      </p:sp>
+      <p:sp>
+        <p:nvSpPr>
+          <p:cNvPr id="21" name="TextBox 20"/>
+          <p:cNvSpPr txBox="1"/>
+          <p:nvPr/>
+        </p:nvSpPr>
+        <p:spPr>
+          <a:xfrm>
+            <a:off x="8302752" y="5394959"/>
+            <a:ext cx="2962656" cy="777240"/>
+          </a:xfrm>
+          <a:prstGeom prst="rect">
+            <a:avLst/>
+          </a:prstGeom>
+          <a:noFill/>
+        </p:spPr>
+        <p:txBody>
+          <a:bodyPr wrap="square">
+            <a:spAutoFit/>
+          </a:bodyPr>
+          <a:lstStyle/>
+          <a:p>
+            <a:pPr algn="ctr">
+              <a:defRPr sz="1050">
+                <a:solidFill>
+                  <a:srgbClr val="F8FAFC"/>
+                </a:solidFill>
+              </a:defRPr>
+            </a:pPr>
+            <a:r>
+              <a:t>Relasi 1:N Supplier, Obat, Pembelian &amp; Batch Detail.</a:t>
+            </a:r>
           </a:p>
         </p:txBody>
       </p:sp>
       <p:pic>
         <p:nvPicPr>
-          <p:cNvPr id="20" name="Picture 19" descr="erd_database.png"/>
+          <p:cNvPr id="25" name="Picture 24">
+            <a:extLst>
+              <a:ext uri="{FF2B5EF4-FFF2-40B4-BE49-F238E27FC236}">
+                <a16:creationId xmlns:a16="http://schemas.microsoft.com/office/drawing/2014/main" id="{49110D84-DE09-950A-7762-BB2061C4B71C}"/>
+              </a:ext>
+            </a:extLst>
+          </p:cNvPr>
           <p:cNvPicPr>
             <a:picLocks noChangeAspect="1"/>
           </p:cNvPicPr>
@@ -6880,49 +7057,14 @@
         </p:blipFill>
         <p:spPr>
           <a:xfrm>
-            <a:off x="8302752" y="2804100"/>
-            <a:ext cx="2962656" cy="1706999"/>
+            <a:off x="8319651" y="2770919"/>
+            <a:ext cx="2928857" cy="1688400"/>
           </a:xfrm>
           <a:prstGeom prst="rect">
             <a:avLst/>
           </a:prstGeom>
         </p:spPr>
       </p:pic>
-      <p:sp>
-        <p:nvSpPr>
-          <p:cNvPr id="21" name="TextBox 20"/>
-          <p:cNvSpPr txBox="1"/>
-          <p:nvPr/>
-        </p:nvSpPr>
-        <p:spPr>
-          <a:xfrm>
-            <a:off x="8302752" y="5394959"/>
-            <a:ext cx="2962656" cy="777240"/>
-          </a:xfrm>
-          <a:prstGeom prst="rect">
-            <a:avLst/>
-          </a:prstGeom>
-          <a:noFill/>
-        </p:spPr>
-        <p:txBody>
-          <a:bodyPr wrap="square">
-            <a:spAutoFit/>
-          </a:bodyPr>
-          <a:lstStyle/>
-          <a:p>
-            <a:pPr algn="ctr">
-              <a:defRPr sz="1050">
-                <a:solidFill>
-                  <a:srgbClr val="F8FAFC"/>
-                </a:solidFill>
-              </a:defRPr>
-            </a:pPr>
-            <a:r>
-              <a:t>Relasi 1:N Supplier, Obat, Pembelian &amp; Batch Detail.</a:t>
-            </a:r>
-          </a:p>
-        </p:txBody>
-      </p:sp>
     </p:spTree>
   </p:cSld>
   <p:clrMapOvr>
@@ -6932,7 +7074,7 @@
 </file>
 
 <file path=ppt/slides/slide6.xml><?xml version="1.0" encoding="utf-8"?>
-<p:sld xmlns:a="http://schemas.openxmlformats.org/drawingml/2006/main" xmlns:p="http://schemas.openxmlformats.org/presentationml/2006/main" xmlns:r="http://schemas.openxmlformats.org/officeDocument/2006/relationships">
+<p:sld xmlns:a="http://schemas.openxmlformats.org/drawingml/2006/main" xmlns:r="http://schemas.openxmlformats.org/officeDocument/2006/relationships" xmlns:p="http://schemas.openxmlformats.org/presentationml/2006/main">
   <p:cSld>
     <p:spTree>
       <p:nvGrpSpPr>
@@ -6940,7 +7082,14 @@
         <p:cNvGrpSpPr/>
         <p:nvPr/>
       </p:nvGrpSpPr>
-      <p:grpSpPr/>
+      <p:grpSpPr>
+        <a:xfrm>
+          <a:off x="0" y="0"/>
+          <a:ext cx="0" cy="0"/>
+          <a:chOff x="0" y="0"/>
+          <a:chExt cx="0" cy="0"/>
+        </a:xfrm>
+      </p:grpSpPr>
       <p:sp>
         <p:nvSpPr>
           <p:cNvPr id="2" name="Rectangle 1"/>
@@ -6981,6 +7130,7 @@
           <a:lstStyle/>
           <a:p>
             <a:pPr algn="ctr"/>
+            <a:endParaRPr/>
           </a:p>
         </p:txBody>
       </p:sp>
@@ -7001,7 +7151,7 @@
           <a:noFill/>
         </p:spPr>
         <p:txBody>
-          <a:bodyPr wrap="square" lIns="0" rIns="0" tIns="0" bIns="0">
+          <a:bodyPr wrap="square" lIns="0" tIns="0" rIns="0" bIns="0">
             <a:spAutoFit/>
           </a:bodyPr>
           <a:lstStyle/>
@@ -7036,7 +7186,7 @@
           <a:noFill/>
         </p:spPr>
         <p:txBody>
-          <a:bodyPr wrap="square" lIns="0" rIns="0" tIns="0" bIns="0">
+          <a:bodyPr wrap="square" lIns="0" tIns="0" rIns="0" bIns="0">
             <a:spAutoFit/>
           </a:bodyPr>
           <a:lstStyle/>
@@ -7094,6 +7244,7 @@
           <a:lstStyle/>
           <a:p>
             <a:pPr algn="ctr"/>
+            <a:endParaRPr/>
           </a:p>
         </p:txBody>
       </p:sp>
@@ -7114,7 +7265,7 @@
           <a:noFill/>
         </p:spPr>
         <p:txBody>
-          <a:bodyPr wrap="none" lIns="0" rIns="0" tIns="0" bIns="0">
+          <a:bodyPr wrap="none" lIns="0" tIns="0" rIns="0" bIns="0">
             <a:spAutoFit/>
           </a:bodyPr>
           <a:lstStyle/>
@@ -7186,6 +7337,7 @@
           <a:lstStyle/>
           <a:p>
             <a:pPr algn="ctr"/>
+            <a:endParaRPr/>
           </a:p>
         </p:txBody>
       </p:sp>
@@ -7226,7 +7378,77 @@
       </p:sp>
       <p:sp>
         <p:nvSpPr>
-          <p:cNvPr id="9" name="TextBox 8"/>
+          <p:cNvPr id="9" name="Rounded Rectangle 8"/>
+          <p:cNvSpPr/>
+          <p:nvPr/>
+        </p:nvSpPr>
+        <p:spPr>
+          <a:xfrm>
+            <a:off x="914400" y="2011680"/>
+            <a:ext cx="4800600" cy="2926080"/>
+          </a:xfrm>
+          <a:prstGeom prst="roundRect">
+            <a:avLst/>
+          </a:prstGeom>
+          <a:solidFill>
+            <a:srgbClr val="0F172A"/>
+          </a:solidFill>
+          <a:ln w="15240">
+            <a:solidFill>
+              <a:srgbClr val="263A5C"/>
+            </a:solidFill>
+          </a:ln>
+        </p:spPr>
+        <p:style>
+          <a:lnRef idx="1">
+            <a:schemeClr val="accent1"/>
+          </a:lnRef>
+          <a:fillRef idx="3">
+            <a:schemeClr val="accent1"/>
+          </a:fillRef>
+          <a:effectRef idx="2">
+            <a:schemeClr val="accent1"/>
+          </a:effectRef>
+          <a:fontRef idx="minor">
+            <a:schemeClr val="lt1"/>
+          </a:fontRef>
+        </p:style>
+        <p:txBody>
+          <a:bodyPr rtlCol="0" anchor="ctr"/>
+          <a:lstStyle/>
+          <a:p>
+            <a:pPr algn="ctr"/>
+            <a:endParaRPr/>
+          </a:p>
+        </p:txBody>
+      </p:sp>
+      <p:pic>
+        <p:nvPicPr>
+          <p:cNvPr id="10" name="Picture 9" descr="ui_pos_kasir.png"/>
+          <p:cNvPicPr>
+            <a:picLocks noChangeAspect="1"/>
+          </p:cNvPicPr>
+          <p:nvPr/>
+        </p:nvPicPr>
+        <p:blipFill>
+          <a:blip r:embed="rId2"/>
+          <a:stretch>
+            <a:fillRect/>
+          </a:stretch>
+        </p:blipFill>
+        <p:spPr>
+          <a:xfrm>
+            <a:off x="914400" y="2051718"/>
+            <a:ext cx="4800600" cy="2846003"/>
+          </a:xfrm>
+          <a:prstGeom prst="rect">
+            <a:avLst/>
+          </a:prstGeom>
+        </p:spPr>
+      </p:pic>
+      <p:sp>
+        <p:nvSpPr>
+          <p:cNvPr id="11" name="TextBox 10"/>
           <p:cNvSpPr txBox="1"/>
           <p:nvPr/>
         </p:nvSpPr>
@@ -7245,7 +7467,9 @@
             <a:spAutoFit/>
           </a:bodyPr>
           <a:lstStyle/>
-          <a:p/>
+          <a:p>
+            <a:endParaRPr/>
+          </a:p>
           <a:p>
             <a:pPr>
               <a:spcBef>
@@ -7295,7 +7519,7 @@
       </p:sp>
       <p:sp>
         <p:nvSpPr>
-          <p:cNvPr id="10" name="Rounded Rectangle 9"/>
+          <p:cNvPr id="12" name="Rounded Rectangle 11"/>
           <p:cNvSpPr/>
           <p:nvPr/>
         </p:nvSpPr>
@@ -7335,12 +7559,13 @@
           <a:lstStyle/>
           <a:p>
             <a:pPr algn="ctr"/>
-          </a:p>
-        </p:txBody>
-      </p:sp>
-      <p:sp>
-        <p:nvSpPr>
-          <p:cNvPr id="11" name="TextBox 10"/>
+            <a:endParaRPr/>
+          </a:p>
+        </p:txBody>
+      </p:sp>
+      <p:sp>
+        <p:nvSpPr>
+          <p:cNvPr id="13" name="TextBox 12"/>
           <p:cNvSpPr txBox="1"/>
           <p:nvPr/>
         </p:nvSpPr>
@@ -7375,7 +7600,77 @@
       </p:sp>
       <p:sp>
         <p:nvSpPr>
-          <p:cNvPr id="12" name="TextBox 11"/>
+          <p:cNvPr id="14" name="Rounded Rectangle 13"/>
+          <p:cNvSpPr/>
+          <p:nvPr/>
+        </p:nvSpPr>
+        <p:spPr>
+          <a:xfrm>
+            <a:off x="6476695" y="2011680"/>
+            <a:ext cx="4800600" cy="2926080"/>
+          </a:xfrm>
+          <a:prstGeom prst="roundRect">
+            <a:avLst/>
+          </a:prstGeom>
+          <a:solidFill>
+            <a:srgbClr val="0F172A"/>
+          </a:solidFill>
+          <a:ln w="15240">
+            <a:solidFill>
+              <a:srgbClr val="263A5C"/>
+            </a:solidFill>
+          </a:ln>
+        </p:spPr>
+        <p:style>
+          <a:lnRef idx="1">
+            <a:schemeClr val="accent1"/>
+          </a:lnRef>
+          <a:fillRef idx="3">
+            <a:schemeClr val="accent1"/>
+          </a:fillRef>
+          <a:effectRef idx="2">
+            <a:schemeClr val="accent1"/>
+          </a:effectRef>
+          <a:fontRef idx="minor">
+            <a:schemeClr val="lt1"/>
+          </a:fontRef>
+        </p:style>
+        <p:txBody>
+          <a:bodyPr rtlCol="0" anchor="ctr"/>
+          <a:lstStyle/>
+          <a:p>
+            <a:pPr algn="ctr"/>
+            <a:endParaRPr/>
+          </a:p>
+        </p:txBody>
+      </p:sp>
+      <p:pic>
+        <p:nvPicPr>
+          <p:cNvPr id="15" name="Picture 14" descr="ui_katalog_obat.png"/>
+          <p:cNvPicPr>
+            <a:picLocks noChangeAspect="1"/>
+          </p:cNvPicPr>
+          <p:nvPr/>
+        </p:nvPicPr>
+        <p:blipFill>
+          <a:blip r:embed="rId3"/>
+          <a:stretch>
+            <a:fillRect/>
+          </a:stretch>
+        </p:blipFill>
+        <p:spPr>
+          <a:xfrm>
+            <a:off x="6476695" y="2051718"/>
+            <a:ext cx="4800600" cy="2846003"/>
+          </a:xfrm>
+          <a:prstGeom prst="rect">
+            <a:avLst/>
+          </a:prstGeom>
+        </p:spPr>
+      </p:pic>
+      <p:sp>
+        <p:nvSpPr>
+          <p:cNvPr id="16" name="TextBox 15"/>
           <p:cNvSpPr txBox="1"/>
           <p:nvPr/>
         </p:nvSpPr>
@@ -7394,7 +7689,9 @@
             <a:spAutoFit/>
           </a:bodyPr>
           <a:lstStyle/>
-          <a:p/>
+          <a:p>
+            <a:endParaRPr/>
+          </a:p>
           <a:p>
             <a:pPr>
               <a:spcBef>
@@ -7451,7 +7748,7 @@
 </file>
 
 <file path=ppt/slides/slide7.xml><?xml version="1.0" encoding="utf-8"?>
-<p:sld xmlns:a="http://schemas.openxmlformats.org/drawingml/2006/main" xmlns:p="http://schemas.openxmlformats.org/presentationml/2006/main" xmlns:r="http://schemas.openxmlformats.org/officeDocument/2006/relationships">
+<p:sld xmlns:a="http://schemas.openxmlformats.org/drawingml/2006/main" xmlns:r="http://schemas.openxmlformats.org/officeDocument/2006/relationships" xmlns:p="http://schemas.openxmlformats.org/presentationml/2006/main">
   <p:cSld>
     <p:spTree>
       <p:nvGrpSpPr>
@@ -7459,7 +7756,14 @@
         <p:cNvGrpSpPr/>
         <p:nvPr/>
       </p:nvGrpSpPr>
-      <p:grpSpPr/>
+      <p:grpSpPr>
+        <a:xfrm>
+          <a:off x="0" y="0"/>
+          <a:ext cx="0" cy="0"/>
+          <a:chOff x="0" y="0"/>
+          <a:chExt cx="0" cy="0"/>
+        </a:xfrm>
+      </p:grpSpPr>
       <p:sp>
         <p:nvSpPr>
           <p:cNvPr id="2" name="Rectangle 1"/>
@@ -7500,6 +7804,7 @@
           <a:lstStyle/>
           <a:p>
             <a:pPr algn="ctr"/>
+            <a:endParaRPr/>
           </a:p>
         </p:txBody>
       </p:sp>
@@ -7520,7 +7825,7 @@
           <a:noFill/>
         </p:spPr>
         <p:txBody>
-          <a:bodyPr wrap="square" lIns="0" rIns="0" tIns="0" bIns="0">
+          <a:bodyPr wrap="square" lIns="0" tIns="0" rIns="0" bIns="0">
             <a:spAutoFit/>
           </a:bodyPr>
           <a:lstStyle/>
@@ -7555,7 +7860,7 @@
           <a:noFill/>
         </p:spPr>
         <p:txBody>
-          <a:bodyPr wrap="square" lIns="0" rIns="0" tIns="0" bIns="0">
+          <a:bodyPr wrap="square" lIns="0" tIns="0" rIns="0" bIns="0">
             <a:spAutoFit/>
           </a:bodyPr>
           <a:lstStyle/>
@@ -7613,6 +7918,7 @@
           <a:lstStyle/>
           <a:p>
             <a:pPr algn="ctr"/>
+            <a:endParaRPr/>
           </a:p>
         </p:txBody>
       </p:sp>
@@ -7633,7 +7939,7 @@
           <a:noFill/>
         </p:spPr>
         <p:txBody>
-          <a:bodyPr wrap="none" lIns="0" rIns="0" tIns="0" bIns="0">
+          <a:bodyPr wrap="none" lIns="0" tIns="0" rIns="0" bIns="0">
             <a:spAutoFit/>
           </a:bodyPr>
           <a:lstStyle/>
@@ -7705,6 +8011,7 @@
           <a:lstStyle/>
           <a:p>
             <a:pPr algn="ctr"/>
+            <a:endParaRPr/>
           </a:p>
         </p:txBody>
       </p:sp>
@@ -7745,7 +8052,77 @@
       </p:sp>
       <p:sp>
         <p:nvSpPr>
-          <p:cNvPr id="9" name="TextBox 8"/>
+          <p:cNvPr id="9" name="Rounded Rectangle 8"/>
+          <p:cNvSpPr/>
+          <p:nvPr/>
+        </p:nvSpPr>
+        <p:spPr>
+          <a:xfrm>
+            <a:off x="914400" y="2011680"/>
+            <a:ext cx="4800600" cy="2926080"/>
+          </a:xfrm>
+          <a:prstGeom prst="roundRect">
+            <a:avLst/>
+          </a:prstGeom>
+          <a:solidFill>
+            <a:srgbClr val="0F172A"/>
+          </a:solidFill>
+          <a:ln w="15240">
+            <a:solidFill>
+              <a:srgbClr val="263A5C"/>
+            </a:solidFill>
+          </a:ln>
+        </p:spPr>
+        <p:style>
+          <a:lnRef idx="1">
+            <a:schemeClr val="accent1"/>
+          </a:lnRef>
+          <a:fillRef idx="3">
+            <a:schemeClr val="accent1"/>
+          </a:fillRef>
+          <a:effectRef idx="2">
+            <a:schemeClr val="accent1"/>
+          </a:effectRef>
+          <a:fontRef idx="minor">
+            <a:schemeClr val="lt1"/>
+          </a:fontRef>
+        </p:style>
+        <p:txBody>
+          <a:bodyPr rtlCol="0" anchor="ctr"/>
+          <a:lstStyle/>
+          <a:p>
+            <a:pPr algn="ctr"/>
+            <a:endParaRPr/>
+          </a:p>
+        </p:txBody>
+      </p:sp>
+      <p:pic>
+        <p:nvPicPr>
+          <p:cNvPr id="10" name="Picture 9" descr="ui_dashboard_admin.png"/>
+          <p:cNvPicPr>
+            <a:picLocks noChangeAspect="1"/>
+          </p:cNvPicPr>
+          <p:nvPr/>
+        </p:nvPicPr>
+        <p:blipFill>
+          <a:blip r:embed="rId2"/>
+          <a:stretch>
+            <a:fillRect/>
+          </a:stretch>
+        </p:blipFill>
+        <p:spPr>
+          <a:xfrm>
+            <a:off x="914400" y="2051718"/>
+            <a:ext cx="4800600" cy="2846003"/>
+          </a:xfrm>
+          <a:prstGeom prst="rect">
+            <a:avLst/>
+          </a:prstGeom>
+        </p:spPr>
+      </p:pic>
+      <p:sp>
+        <p:nvSpPr>
+          <p:cNvPr id="11" name="TextBox 10"/>
           <p:cNvSpPr txBox="1"/>
           <p:nvPr/>
         </p:nvSpPr>
@@ -7764,7 +8141,9 @@
             <a:spAutoFit/>
           </a:bodyPr>
           <a:lstStyle/>
-          <a:p/>
+          <a:p>
+            <a:endParaRPr/>
+          </a:p>
           <a:p>
             <a:pPr>
               <a:spcBef>
@@ -7814,7 +8193,7 @@
       </p:sp>
       <p:sp>
         <p:nvSpPr>
-          <p:cNvPr id="10" name="Rounded Rectangle 9"/>
+          <p:cNvPr id="12" name="Rounded Rectangle 11"/>
           <p:cNvSpPr/>
           <p:nvPr/>
         </p:nvSpPr>
@@ -7854,12 +8233,13 @@
           <a:lstStyle/>
           <a:p>
             <a:pPr algn="ctr"/>
-          </a:p>
-        </p:txBody>
-      </p:sp>
-      <p:sp>
-        <p:nvSpPr>
-          <p:cNvPr id="11" name="TextBox 10"/>
+            <a:endParaRPr/>
+          </a:p>
+        </p:txBody>
+      </p:sp>
+      <p:sp>
+        <p:nvSpPr>
+          <p:cNvPr id="13" name="TextBox 12"/>
           <p:cNvSpPr txBox="1"/>
           <p:nvPr/>
         </p:nvSpPr>
@@ -7894,7 +8274,77 @@
       </p:sp>
       <p:sp>
         <p:nvSpPr>
-          <p:cNvPr id="12" name="TextBox 11"/>
+          <p:cNvPr id="14" name="Rounded Rectangle 13"/>
+          <p:cNvSpPr/>
+          <p:nvPr/>
+        </p:nvSpPr>
+        <p:spPr>
+          <a:xfrm>
+            <a:off x="6476695" y="2011680"/>
+            <a:ext cx="4800600" cy="2926080"/>
+          </a:xfrm>
+          <a:prstGeom prst="roundRect">
+            <a:avLst/>
+          </a:prstGeom>
+          <a:solidFill>
+            <a:srgbClr val="0F172A"/>
+          </a:solidFill>
+          <a:ln w="15240">
+            <a:solidFill>
+              <a:srgbClr val="263A5C"/>
+            </a:solidFill>
+          </a:ln>
+        </p:spPr>
+        <p:style>
+          <a:lnRef idx="1">
+            <a:schemeClr val="accent1"/>
+          </a:lnRef>
+          <a:fillRef idx="3">
+            <a:schemeClr val="accent1"/>
+          </a:fillRef>
+          <a:effectRef idx="2">
+            <a:schemeClr val="accent1"/>
+          </a:effectRef>
+          <a:fontRef idx="minor">
+            <a:schemeClr val="lt1"/>
+          </a:fontRef>
+        </p:style>
+        <p:txBody>
+          <a:bodyPr rtlCol="0" anchor="ctr"/>
+          <a:lstStyle/>
+          <a:p>
+            <a:pPr algn="ctr"/>
+            <a:endParaRPr/>
+          </a:p>
+        </p:txBody>
+      </p:sp>
+      <p:pic>
+        <p:nvPicPr>
+          <p:cNvPr id="15" name="Picture 14" descr="ui_tabel_restock.png"/>
+          <p:cNvPicPr>
+            <a:picLocks noChangeAspect="1"/>
+          </p:cNvPicPr>
+          <p:nvPr/>
+        </p:nvPicPr>
+        <p:blipFill>
+          <a:blip r:embed="rId3"/>
+          <a:stretch>
+            <a:fillRect/>
+          </a:stretch>
+        </p:blipFill>
+        <p:spPr>
+          <a:xfrm>
+            <a:off x="6476695" y="2051718"/>
+            <a:ext cx="4800600" cy="2846003"/>
+          </a:xfrm>
+          <a:prstGeom prst="rect">
+            <a:avLst/>
+          </a:prstGeom>
+        </p:spPr>
+      </p:pic>
+      <p:sp>
+        <p:nvSpPr>
+          <p:cNvPr id="16" name="TextBox 15"/>
           <p:cNvSpPr txBox="1"/>
           <p:nvPr/>
         </p:nvSpPr>
@@ -7913,7 +8363,9 @@
             <a:spAutoFit/>
           </a:bodyPr>
           <a:lstStyle/>
-          <a:p/>
+          <a:p>
+            <a:endParaRPr/>
+          </a:p>
           <a:p>
             <a:pPr>
               <a:spcBef>
@@ -7970,7 +8422,7 @@
 </file>
 
 <file path=ppt/slides/slide8.xml><?xml version="1.0" encoding="utf-8"?>
-<p:sld xmlns:a="http://schemas.openxmlformats.org/drawingml/2006/main" xmlns:p="http://schemas.openxmlformats.org/presentationml/2006/main" xmlns:r="http://schemas.openxmlformats.org/officeDocument/2006/relationships">
+<p:sld xmlns:a="http://schemas.openxmlformats.org/drawingml/2006/main" xmlns:r="http://schemas.openxmlformats.org/officeDocument/2006/relationships" xmlns:p="http://schemas.openxmlformats.org/presentationml/2006/main">
   <p:cSld>
     <p:spTree>
       <p:nvGrpSpPr>
@@ -7978,7 +8430,14 @@
         <p:cNvGrpSpPr/>
         <p:nvPr/>
       </p:nvGrpSpPr>
-      <p:grpSpPr/>
+      <p:grpSpPr>
+        <a:xfrm>
+          <a:off x="0" y="0"/>
+          <a:ext cx="0" cy="0"/>
+          <a:chOff x="0" y="0"/>
+          <a:chExt cx="0" cy="0"/>
+        </a:xfrm>
+      </p:grpSpPr>
       <p:sp>
         <p:nvSpPr>
           <p:cNvPr id="2" name="Rectangle 1"/>
@@ -8019,6 +8478,7 @@
           <a:lstStyle/>
           <a:p>
             <a:pPr algn="ctr"/>
+            <a:endParaRPr/>
           </a:p>
         </p:txBody>
       </p:sp>
@@ -8039,7 +8499,7 @@
           <a:noFill/>
         </p:spPr>
         <p:txBody>
-          <a:bodyPr wrap="square" lIns="0" rIns="0" tIns="0" bIns="0">
+          <a:bodyPr wrap="square" lIns="0" tIns="0" rIns="0" bIns="0">
             <a:spAutoFit/>
           </a:bodyPr>
           <a:lstStyle/>
@@ -8074,7 +8534,7 @@
           <a:noFill/>
         </p:spPr>
         <p:txBody>
-          <a:bodyPr wrap="square" lIns="0" rIns="0" tIns="0" bIns="0">
+          <a:bodyPr wrap="square" lIns="0" tIns="0" rIns="0" bIns="0">
             <a:spAutoFit/>
           </a:bodyPr>
           <a:lstStyle/>
@@ -8132,6 +8592,7 @@
           <a:lstStyle/>
           <a:p>
             <a:pPr algn="ctr"/>
+            <a:endParaRPr/>
           </a:p>
         </p:txBody>
       </p:sp>
@@ -8152,7 +8613,7 @@
           <a:noFill/>
         </p:spPr>
         <p:txBody>
-          <a:bodyPr wrap="none" lIns="0" rIns="0" tIns="0" bIns="0">
+          <a:bodyPr wrap="none" lIns="0" tIns="0" rIns="0" bIns="0">
             <a:spAutoFit/>
           </a:bodyPr>
           <a:lstStyle/>
@@ -8224,6 +8685,7 @@
           <a:lstStyle/>
           <a:p>
             <a:pPr algn="ctr"/>
+            <a:endParaRPr/>
           </a:p>
         </p:txBody>
       </p:sp>
@@ -8394,6 +8856,7 @@
           <a:lstStyle/>
           <a:p>
             <a:pPr algn="ctr"/>
+            <a:endParaRPr/>
           </a:p>
         </p:txBody>
       </p:sp>

</xml_diff>